<commit_message>
Correct roster: Suranjit Paul is an instructor, not a group member
Group 1 is Abdul-Ramon Adeyemi Folarin, Immanuel Guarin and Sherman Law;
instructors are Suranjit Paul and Mark Shtern - fixed on the report
title page and the deck title slide.

Co-authored-by: Adeyemi Folarin <devzephyr@users.noreply.github.com>
</commit_message>
<xml_diff>
--- a/devsecops/deliverables/DevSecOps_Slides.pptx
+++ b/devsecops/deliverables/DevSecOps_Slides.pptx
@@ -2154,7 +2154,7 @@
                   <a:srgbClr val="FFFFFF"/>
                 </a:solidFill>
               </a:rPr>
-              <a:t>Group 1: Abdul-Ramon Adeyemi Folarin  ·  Immanuel Guarin  ·  Sherman Law  ·  Suranjit Paul</a:t>
+              <a:t>Group 1: Abdul-Ramon Adeyemi Folarin  ·  Immanuel Guarin  ·  Sherman Law</a:t>
             </a:r>
             <a:endParaRPr lang="en-US" sz="1400" dirty="0"/>
           </a:p>
@@ -2169,7 +2169,7 @@
         <p:spPr>
           <a:xfrm>
             <a:off x="731520" y="5897880"/>
-            <a:ext cx="9144000" cy="320040"/>
+            <a:ext cx="9601200" cy="320040"/>
           </a:xfrm>
           <a:prstGeom prst="rect">
             <a:avLst/>
@@ -2190,7 +2190,7 @@
                   <a:srgbClr val="D8DCE4"/>
                 </a:solidFill>
               </a:rPr>
-              <a:t>Application Security Methodology  |  Instructor: Mark Shtern  |  August 2026</a:t>
+              <a:t>Application Security Methodology  |  Instructors: Suranjit Paul &amp; Mark Shtern  |  August 2026</a:t>
             </a:r>
             <a:endParaRPr lang="en-US" sz="1200" dirty="0"/>
           </a:p>

</xml_diff>

<commit_message>
Record the upstream patch of GHSA-pjrx (kimai/kimai#6089)
The advisory initially declined as documented behavior was patched
upstream exactly as proposed: role management now respects the role
hierarchy (merged 2026-08-02). Updated the bug report doc, the LNCS
report, the deck and the checklist - maintainer approval is now met
through the merged upstream fix.

Co-authored-by: Adeyemi Folarin <devzephyr@users.noreply.github.com>
</commit_message>
<xml_diff>
--- a/devsecops/deliverables/DevSecOps_Slides.pptx
+++ b/devsecops/deliverables/DevSecOps_Slides.pptx
@@ -6307,7 +6307,7 @@
                   <a:srgbClr val="232A33"/>
                 </a:solidFill>
               </a:rPr>
-              <a:t>GHSA-pjrx-mwv9-j9vf was rejected: documented behavior, super-admin-only by default. Verify the documented threat model before filing.</a:t>
+              <a:t>GHSA-pjrx-mwv9-j9vf: first declined as 'documented behavior' - then patched upstream exactly as proposed (kimai/kimai PR #6089, merged Aug 2026). A well-argued report lands even when the first answer is 'by design'.</a:t>
             </a:r>
             <a:endParaRPr lang="en-US" sz="1150" dirty="0"/>
           </a:p>
@@ -7135,7 +7135,7 @@
                   <a:srgbClr val="D8DCE4"/>
                 </a:solidFill>
               </a:rPr>
-              <a:t>Read the documented threat model before filing (rejected advisory)</a:t>
+              <a:t>A well-argued report lands even after a 'by design' answer (GHSA-pjrx patched upstream)</a:t>
             </a:r>
             <a:endParaRPr lang="en-US" sz="1500" dirty="0"/>
           </a:p>

</xml_diff>